<commit_message>
Source pptx: subtler pink, slide 2 reworked
</commit_message>
<xml_diff>
--- a/breaking-bad-present-continuous.pptx
+++ b/breaking-bad-present-continuous.pptx
@@ -192,7 +192,7 @@
         <a:srgbClr val="156082"/>
       </a:accent1>
       <a:accent2>
-        <a:srgbClr val="ED6458"/>
+        <a:srgbClr val="E96235"/>
       </a:accent2>
       <a:accent3>
         <a:srgbClr val="196B24"/>
@@ -2037,7 +2037,7 @@
         <a:srgbClr val="156082"/>
       </a:accent1>
       <a:accent2>
-        <a:srgbClr val="ED6458"/>
+        <a:srgbClr val="E96235"/>
       </a:accent2>
       <a:accent3>
         <a:srgbClr val="196B24"/>
@@ -2361,14 +2361,14 @@
               <a:buNone/>
               <a:defRPr sz="4200" b="1">
                 <a:solidFill>
-                  <a:srgbClr val="F794AB"/>
+                  <a:srgbClr val="F2738C"/>
                 </a:solidFill>
               </a:defRPr>
             </a:pPr>
             <a:r>
               <a:rPr sz="3600" b="1">
                 <a:solidFill>
-                  <a:srgbClr val="F794AB"/>
+                  <a:srgbClr val="F2738C"/>
                 </a:solidFill>
                 <a:latin typeface="Courier New"/>
                 <a:ea typeface="Courier New"/>
@@ -2380,7 +2380,7 @@
             <a:r>
               <a:rPr sz="3600" b="1">
                 <a:solidFill>
-                  <a:srgbClr val="F794AB"/>
+                  <a:srgbClr val="F2738C"/>
                 </a:solidFill>
                 <a:latin typeface="Courier New"/>
                 <a:ea typeface="Courier New"/>
@@ -2391,7 +2391,7 @@
             <a:r>
               <a:rPr sz="3600" b="1">
                 <a:solidFill>
-                  <a:srgbClr val="F794AB"/>
+                  <a:srgbClr val="F2738C"/>
                 </a:solidFill>
                 <a:latin typeface="Courier New"/>
                 <a:ea typeface="Courier New"/>
@@ -2402,7 +2402,7 @@
             <a:r>
               <a:rPr sz="3600" b="1">
                 <a:solidFill>
-                  <a:srgbClr val="F794AB"/>
+                  <a:srgbClr val="F2738C"/>
                 </a:solidFill>
                 <a:latin typeface="Courier New"/>
                 <a:ea typeface="Courier New"/>
@@ -2412,7 +2412,7 @@
             </a:r>
             <a:endParaRPr sz="3600" b="1">
               <a:solidFill>
-                <a:srgbClr val="F794AB"/>
+                <a:srgbClr val="F2738C"/>
               </a:solidFill>
               <a:latin typeface="Courier New"/>
               <a:ea typeface="Courier New"/>
@@ -2688,14 +2688,14 @@
               <a:buNone/>
               <a:defRPr sz="1500" b="1">
                 <a:solidFill>
-                  <a:srgbClr val="F794AB"/>
+                  <a:srgbClr val="F2738C"/>
                 </a:solidFill>
               </a:defRPr>
             </a:pPr>
             <a:r>
               <a:rPr sz="1500" b="1">
                 <a:solidFill>
-                  <a:srgbClr val="F794AB"/>
+                  <a:srgbClr val="F2738C"/>
                 </a:solidFill>
                 <a:latin typeface="Courier New"/>
                 <a:ea typeface="Courier New"/>
@@ -2706,7 +2706,7 @@
             <a:r>
               <a:rPr sz="1500" b="1">
                 <a:solidFill>
-                  <a:srgbClr val="F794AB"/>
+                  <a:srgbClr val="F2738C"/>
                 </a:solidFill>
                 <a:latin typeface="Courier New"/>
                 <a:ea typeface="Courier New"/>
@@ -2717,7 +2717,7 @@
             <a:r>
               <a:rPr sz="1500" b="1">
                 <a:solidFill>
-                  <a:srgbClr val="F794AB"/>
+                  <a:srgbClr val="F2738C"/>
                 </a:solidFill>
                 <a:latin typeface="Courier New"/>
                 <a:ea typeface="Courier New"/>
@@ -2727,7 +2727,7 @@
             </a:r>
             <a:endParaRPr sz="1500" b="1">
               <a:solidFill>
-                <a:srgbClr val="F794AB"/>
+                <a:srgbClr val="F2738C"/>
               </a:solidFill>
             </a:endParaRPr>
           </a:p>
@@ -3721,14 +3721,14 @@
               <a:buNone/>
               <a:defRPr sz="3600" b="1">
                 <a:solidFill>
-                  <a:srgbClr val="F794AB"/>
+                  <a:srgbClr val="F2738C"/>
                 </a:solidFill>
               </a:defRPr>
             </a:pPr>
             <a:r>
               <a:rPr sz="3600" b="1">
                 <a:solidFill>
-                  <a:srgbClr val="F794AB"/>
+                  <a:srgbClr val="F2738C"/>
                 </a:solidFill>
                 <a:latin typeface="Courier New"/>
                 <a:ea typeface="Courier New"/>
@@ -3738,7 +3738,7 @@
             </a:r>
             <a:endParaRPr sz="3600" b="1">
               <a:solidFill>
-                <a:srgbClr val="F794AB"/>
+                <a:srgbClr val="F2738C"/>
               </a:solidFill>
               <a:latin typeface="Courier New"/>
               <a:ea typeface="Courier New"/>
@@ -4399,7 +4399,7 @@
               <a:buNone/>
               <a:defRPr sz="1575" b="1">
                 <a:solidFill>
-                  <a:srgbClr val="F794AB"/>
+                  <a:srgbClr val="F2738C"/>
                 </a:solidFill>
               </a:defRPr>
             </a:pPr>
@@ -4460,7 +4460,7 @@
               <a:buNone/>
               <a:defRPr sz="1575" b="1">
                 <a:solidFill>
-                  <a:srgbClr val="F794AB"/>
+                  <a:srgbClr val="F2738C"/>
                 </a:solidFill>
               </a:defRPr>
             </a:pPr>
@@ -4521,7 +4521,7 @@
               <a:buNone/>
               <a:defRPr sz="1575" b="1">
                 <a:solidFill>
-                  <a:srgbClr val="F794AB"/>
+                  <a:srgbClr val="F2738C"/>
                 </a:solidFill>
               </a:defRPr>
             </a:pPr>
@@ -4566,8 +4566,15 @@
             <a:off x="762000" y="2628900"/>
             <a:ext cx="2381250" cy="1162050"/>
           </a:xfrm>
-          <a:prstGeom xmlns:a="http://schemas.openxmlformats.org/drawingml/2006/main" prst="rect">
-            <a:avLst/>
+          <a:solidFill xmlns:a="http://schemas.openxmlformats.org/drawingml/2006/main">
+            <a:srgbClr val="F2738C">
+              <a:alpha val="16000"/>
+            </a:srgbClr>
+          </a:solidFill>
+          <a:prstGeom xmlns:a="http://schemas.openxmlformats.org/drawingml/2006/main" prst="roundRect">
+            <a:avLst>
+              <a:gd name="adj" fmla="val 9000"/>
+            </a:avLst>
           </a:prstGeom>
           <a:ln xmlns:a="http://schemas.openxmlformats.org/drawingml/2006/main" w="0">
             <a:noFill/>
@@ -4593,8 +4600,15 @@
             <a:off x="3524250" y="2628900"/>
             <a:ext cx="2952750" cy="1162050"/>
           </a:xfrm>
-          <a:prstGeom xmlns:a="http://schemas.openxmlformats.org/drawingml/2006/main" prst="rect">
-            <a:avLst/>
+          <a:solidFill xmlns:a="http://schemas.openxmlformats.org/drawingml/2006/main">
+            <a:srgbClr val="F2738C">
+              <a:alpha val="16000"/>
+            </a:srgbClr>
+          </a:solidFill>
+          <a:prstGeom xmlns:a="http://schemas.openxmlformats.org/drawingml/2006/main" prst="roundRect">
+            <a:avLst>
+              <a:gd name="adj" fmla="val 9000"/>
+            </a:avLst>
           </a:prstGeom>
           <a:ln xmlns:a="http://schemas.openxmlformats.org/drawingml/2006/main" w="0">
             <a:noFill/>
@@ -4620,8 +4634,15 @@
             <a:off x="6953250" y="2628900"/>
             <a:ext cx="2952750" cy="1162050"/>
           </a:xfrm>
-          <a:prstGeom xmlns:a="http://schemas.openxmlformats.org/drawingml/2006/main" prst="rect">
-            <a:avLst/>
+          <a:solidFill xmlns:a="http://schemas.openxmlformats.org/drawingml/2006/main">
+            <a:srgbClr val="F2738C">
+              <a:alpha val="16000"/>
+            </a:srgbClr>
+          </a:solidFill>
+          <a:prstGeom xmlns:a="http://schemas.openxmlformats.org/drawingml/2006/main" prst="roundRect">
+            <a:avLst>
+              <a:gd name="adj" fmla="val 9000"/>
+            </a:avLst>
           </a:prstGeom>
           <a:ln xmlns:a="http://schemas.openxmlformats.org/drawingml/2006/main" w="0">
             <a:noFill/>
@@ -4927,6 +4948,31 @@
           </a:p>
         </p:txBody>
       </p:sp>
+      <p:pic>
+        <p:nvPicPr>
+          <p:cNvPr id="950" name="Jessie panel" descr="Jessie is smoking"/>
+          <p:cNvPicPr>
+            <a:picLocks xmlns:a="http://schemas.openxmlformats.org/drawingml/2006/main" noChangeAspect="0"/>
+          </p:cNvPicPr>
+          <p:nvPr/>
+        </p:nvPicPr>
+        <p:blipFill xmlns:a="http://schemas.openxmlformats.org/drawingml/2006/main">
+          <a:blip xmlns:r="http://schemas.openxmlformats.org/officeDocument/2006/relationships" r:embed="rIdJessie"/>
+          <a:srcRect l="24000" r="59500"/>
+          <a:stretch>
+            <a:fillRect/>
+          </a:stretch>
+        </p:blipFill>
+        <p:spPr>
+          <a:xfrm xmlns:a="http://schemas.openxmlformats.org/drawingml/2006/main">
+            <a:off x="10160000" y="0"/>
+            <a:ext cx="2032000" cy="6858000"/>
+          </a:xfrm>
+          <a:prstGeom xmlns:a="http://schemas.openxmlformats.org/drawingml/2006/main" prst="rect">
+            <a:avLst/>
+          </a:prstGeom>
+        </p:spPr>
+      </p:pic>
     </p:spTree>
     <p:extLst>
       <p:ext uri="{BB962C8B-B14F-4D97-AF65-F5344CB8AC3E}">
@@ -5036,7 +5082,7 @@
               <a:buNone/>
               <a:defRPr sz="1500" b="1">
                 <a:solidFill>
-                  <a:srgbClr val="F794AB"/>
+                  <a:srgbClr val="F2738C"/>
                 </a:solidFill>
               </a:defRPr>
             </a:pPr>
@@ -5259,7 +5305,7 @@
               <a:buNone/>
               <a:defRPr sz="1500" b="1">
                 <a:solidFill>
-                  <a:srgbClr val="F794AB"/>
+                  <a:srgbClr val="F2738C"/>
                 </a:solidFill>
               </a:defRPr>
             </a:pPr>
@@ -5652,14 +5698,14 @@
               <a:buNone/>
               <a:defRPr sz="1500" b="1">
                 <a:solidFill>
-                  <a:srgbClr val="F794AB"/>
+                  <a:srgbClr val="F2738C"/>
                 </a:solidFill>
               </a:defRPr>
             </a:pPr>
             <a:r>
               <a:rPr sz="1000" b="1">
                 <a:solidFill>
-                  <a:srgbClr val="F794AB"/>
+                  <a:srgbClr val="F2738C"/>
                 </a:solidFill>
                 <a:latin typeface="Courier New"/>
                 <a:ea typeface="Courier New"/>
@@ -5669,7 +5715,7 @@
             </a:r>
             <a:endParaRPr sz="1000" b="1">
               <a:solidFill>
-                <a:srgbClr val="F794AB"/>
+                <a:srgbClr val="F2738C"/>
               </a:solidFill>
               <a:latin typeface="Courier New"/>
               <a:ea typeface="Courier New"/>
@@ -6257,7 +6303,7 @@
               <a:buNone/>
               <a:defRPr sz="1500" b="1">
                 <a:solidFill>
-                  <a:srgbClr val="F794AB"/>
+                  <a:srgbClr val="F2738C"/>
                 </a:solidFill>
               </a:defRPr>
             </a:pPr>
@@ -6409,7 +6455,7 @@
         <a:srgbClr val="156082"/>
       </a:accent1>
       <a:accent2>
-        <a:srgbClr val="ED6458"/>
+        <a:srgbClr val="E96235"/>
       </a:accent2>
       <a:accent3>
         <a:srgbClr val="196B24"/>

</xml_diff>

<commit_message>
Decks to the top of the library, maximise mode, and the pending pptx
</commit_message>
<xml_diff>
--- a/breaking-bad-present-continuous.pptx
+++ b/breaking-bad-present-continuous.pptx
@@ -192,7 +192,7 @@
         <a:srgbClr val="156082"/>
       </a:accent1>
       <a:accent2>
-        <a:srgbClr val="E96235"/>
+        <a:srgbClr val="E9673C"/>
       </a:accent2>
       <a:accent3>
         <a:srgbClr val="196B24"/>
@@ -2037,7 +2037,7 @@
         <a:srgbClr val="156082"/>
       </a:accent1>
       <a:accent2>
-        <a:srgbClr val="E96235"/>
+        <a:srgbClr val="E9673C"/>
       </a:accent2>
       <a:accent3>
         <a:srgbClr val="196B24"/>
@@ -2361,14 +2361,14 @@
               <a:buNone/>
               <a:defRPr sz="4200" b="1">
                 <a:solidFill>
-                  <a:srgbClr val="F2738C"/>
+                  <a:srgbClr val="F28FA3"/>
                 </a:solidFill>
               </a:defRPr>
             </a:pPr>
             <a:r>
               <a:rPr sz="3600" b="1">
                 <a:solidFill>
-                  <a:srgbClr val="F2738C"/>
+                  <a:srgbClr val="F28FA3"/>
                 </a:solidFill>
                 <a:latin typeface="Courier New"/>
                 <a:ea typeface="Courier New"/>
@@ -2380,7 +2380,7 @@
             <a:r>
               <a:rPr sz="3600" b="1">
                 <a:solidFill>
-                  <a:srgbClr val="F2738C"/>
+                  <a:srgbClr val="F28FA3"/>
                 </a:solidFill>
                 <a:latin typeface="Courier New"/>
                 <a:ea typeface="Courier New"/>
@@ -2391,7 +2391,7 @@
             <a:r>
               <a:rPr sz="3600" b="1">
                 <a:solidFill>
-                  <a:srgbClr val="F2738C"/>
+                  <a:srgbClr val="F28FA3"/>
                 </a:solidFill>
                 <a:latin typeface="Courier New"/>
                 <a:ea typeface="Courier New"/>
@@ -2402,7 +2402,7 @@
             <a:r>
               <a:rPr sz="3600" b="1">
                 <a:solidFill>
-                  <a:srgbClr val="F2738C"/>
+                  <a:srgbClr val="F28FA3"/>
                 </a:solidFill>
                 <a:latin typeface="Courier New"/>
                 <a:ea typeface="Courier New"/>
@@ -2412,7 +2412,7 @@
             </a:r>
             <a:endParaRPr sz="3600" b="1">
               <a:solidFill>
-                <a:srgbClr val="F2738C"/>
+                <a:srgbClr val="F28FA3"/>
               </a:solidFill>
               <a:latin typeface="Courier New"/>
               <a:ea typeface="Courier New"/>
@@ -2688,14 +2688,14 @@
               <a:buNone/>
               <a:defRPr sz="1500" b="1">
                 <a:solidFill>
-                  <a:srgbClr val="F2738C"/>
+                  <a:srgbClr val="F28FA3"/>
                 </a:solidFill>
               </a:defRPr>
             </a:pPr>
             <a:r>
               <a:rPr sz="1500" b="1">
                 <a:solidFill>
-                  <a:srgbClr val="F2738C"/>
+                  <a:srgbClr val="F28FA3"/>
                 </a:solidFill>
                 <a:latin typeface="Courier New"/>
                 <a:ea typeface="Courier New"/>
@@ -2706,7 +2706,7 @@
             <a:r>
               <a:rPr sz="1500" b="1">
                 <a:solidFill>
-                  <a:srgbClr val="F2738C"/>
+                  <a:srgbClr val="F28FA3"/>
                 </a:solidFill>
                 <a:latin typeface="Courier New"/>
                 <a:ea typeface="Courier New"/>
@@ -2717,7 +2717,7 @@
             <a:r>
               <a:rPr sz="1500" b="1">
                 <a:solidFill>
-                  <a:srgbClr val="F2738C"/>
+                  <a:srgbClr val="F28FA3"/>
                 </a:solidFill>
                 <a:latin typeface="Courier New"/>
                 <a:ea typeface="Courier New"/>
@@ -2727,7 +2727,7 @@
             </a:r>
             <a:endParaRPr sz="1500" b="1">
               <a:solidFill>
-                <a:srgbClr val="F2738C"/>
+                <a:srgbClr val="F28FA3"/>
               </a:solidFill>
             </a:endParaRPr>
           </a:p>
@@ -3721,14 +3721,14 @@
               <a:buNone/>
               <a:defRPr sz="3600" b="1">
                 <a:solidFill>
-                  <a:srgbClr val="F2738C"/>
+                  <a:srgbClr val="F28FA3"/>
                 </a:solidFill>
               </a:defRPr>
             </a:pPr>
             <a:r>
               <a:rPr sz="3600" b="1">
                 <a:solidFill>
-                  <a:srgbClr val="F2738C"/>
+                  <a:srgbClr val="F28FA3"/>
                 </a:solidFill>
                 <a:latin typeface="Courier New"/>
                 <a:ea typeface="Courier New"/>
@@ -3738,7 +3738,7 @@
             </a:r>
             <a:endParaRPr sz="3600" b="1">
               <a:solidFill>
-                <a:srgbClr val="F2738C"/>
+                <a:srgbClr val="F28FA3"/>
               </a:solidFill>
               <a:latin typeface="Courier New"/>
               <a:ea typeface="Courier New"/>
@@ -4399,7 +4399,7 @@
               <a:buNone/>
               <a:defRPr sz="1575" b="1">
                 <a:solidFill>
-                  <a:srgbClr val="F2738C"/>
+                  <a:srgbClr val="F28FA3"/>
                 </a:solidFill>
               </a:defRPr>
             </a:pPr>
@@ -4460,7 +4460,7 @@
               <a:buNone/>
               <a:defRPr sz="1575" b="1">
                 <a:solidFill>
-                  <a:srgbClr val="F2738C"/>
+                  <a:srgbClr val="F28FA3"/>
                 </a:solidFill>
               </a:defRPr>
             </a:pPr>
@@ -4521,7 +4521,7 @@
               <a:buNone/>
               <a:defRPr sz="1575" b="1">
                 <a:solidFill>
-                  <a:srgbClr val="F2738C"/>
+                  <a:srgbClr val="F28FA3"/>
                 </a:solidFill>
               </a:defRPr>
             </a:pPr>
@@ -4567,8 +4567,8 @@
             <a:ext cx="2381250" cy="1162050"/>
           </a:xfrm>
           <a:solidFill xmlns:a="http://schemas.openxmlformats.org/drawingml/2006/main">
-            <a:srgbClr val="F2738C">
-              <a:alpha val="16000"/>
+            <a:srgbClr val="F28FA3">
+              <a:alpha val="20000"/>
             </a:srgbClr>
           </a:solidFill>
           <a:prstGeom xmlns:a="http://schemas.openxmlformats.org/drawingml/2006/main" prst="roundRect">
@@ -4601,8 +4601,8 @@
             <a:ext cx="2952750" cy="1162050"/>
           </a:xfrm>
           <a:solidFill xmlns:a="http://schemas.openxmlformats.org/drawingml/2006/main">
-            <a:srgbClr val="F2738C">
-              <a:alpha val="16000"/>
+            <a:srgbClr val="F28FA3">
+              <a:alpha val="20000"/>
             </a:srgbClr>
           </a:solidFill>
           <a:prstGeom xmlns:a="http://schemas.openxmlformats.org/drawingml/2006/main" prst="roundRect">
@@ -4635,8 +4635,8 @@
             <a:ext cx="2952750" cy="1162050"/>
           </a:xfrm>
           <a:solidFill xmlns:a="http://schemas.openxmlformats.org/drawingml/2006/main">
-            <a:srgbClr val="F2738C">
-              <a:alpha val="16000"/>
+            <a:srgbClr val="F28FA3">
+              <a:alpha val="20000"/>
             </a:srgbClr>
           </a:solidFill>
           <a:prstGeom xmlns:a="http://schemas.openxmlformats.org/drawingml/2006/main" prst="roundRect">
@@ -5082,7 +5082,7 @@
               <a:buNone/>
               <a:defRPr sz="1500" b="1">
                 <a:solidFill>
-                  <a:srgbClr val="F2738C"/>
+                  <a:srgbClr val="F28FA3"/>
                 </a:solidFill>
               </a:defRPr>
             </a:pPr>
@@ -5305,7 +5305,7 @@
               <a:buNone/>
               <a:defRPr sz="1500" b="1">
                 <a:solidFill>
-                  <a:srgbClr val="F2738C"/>
+                  <a:srgbClr val="F28FA3"/>
                 </a:solidFill>
               </a:defRPr>
             </a:pPr>
@@ -5698,14 +5698,14 @@
               <a:buNone/>
               <a:defRPr sz="1500" b="1">
                 <a:solidFill>
-                  <a:srgbClr val="F2738C"/>
+                  <a:srgbClr val="F28FA3"/>
                 </a:solidFill>
               </a:defRPr>
             </a:pPr>
             <a:r>
               <a:rPr sz="1000" b="1">
                 <a:solidFill>
-                  <a:srgbClr val="F2738C"/>
+                  <a:srgbClr val="F28FA3"/>
                 </a:solidFill>
                 <a:latin typeface="Courier New"/>
                 <a:ea typeface="Courier New"/>
@@ -5715,7 +5715,7 @@
             </a:r>
             <a:endParaRPr sz="1000" b="1">
               <a:solidFill>
-                <a:srgbClr val="F2738C"/>
+                <a:srgbClr val="F28FA3"/>
               </a:solidFill>
               <a:latin typeface="Courier New"/>
               <a:ea typeface="Courier New"/>
@@ -6303,7 +6303,7 @@
               <a:buNone/>
               <a:defRPr sz="1500" b="1">
                 <a:solidFill>
-                  <a:srgbClr val="F2738C"/>
+                  <a:srgbClr val="F28FA3"/>
                 </a:solidFill>
               </a:defRPr>
             </a:pPr>
@@ -6455,7 +6455,7 @@
         <a:srgbClr val="156082"/>
       </a:accent1>
       <a:accent2>
-        <a:srgbClr val="E96235"/>
+        <a:srgbClr val="E9673C"/>
       </a:accent2>
       <a:accent3>
         <a:srgbClr val="196B24"/>

</xml_diff>